<commit_message>
docs(presentation): le support integre le parcours patient
Trois passages disaient que le patient ne reserve pas — dont une note
d'orateur et une reponse preparee aux questions. Les tenir sur scene
aurait contredit la demonstration qui suit.

- scenario de demo : 9 etapes, la patiente reserve avant l'appel
  telephonique, et la reception constate que le creneau a disparu ;
- ecran de secours : le compte patient s'affiche avec les deux autres ;
- « portail patient en libre-service » quitte les pistes d'amelioration
  (livre) et cede la place a l'annulation par le patient, qui elle
  reste a faire ;
- chiffres : 9 fonctionnalites, 199 tests (67 backend, 132 frontend) ;
- question preparee remplacee par la bonne, plus une sur l'annulation.

PPTX regenere : 16 diapositives.
</commit_message>
<xml_diff>
--- a/docs/presentation/MediPlan-Presentation-Finale.pptx
+++ b/docs/presentation/MediPlan-Presentation-Finale.pptx
@@ -699,7 +699,7 @@
           <a:p/>
           <a:p>
             <a:r>
-              <a:t>« Nous avons 186 tests automatisés : 57 côté serveur, 129 côté interface. Ils tournent à chaque push, et une pull request dont la CI est rouge n'est pas fusionnée.</a:t>
+              <a:t>« Nous avons 199 tests automatisés : 67 côté serveur, 132 côté interface. Ils tournent à chaque push, et une pull request dont la CI est rouge n'est pas fusionnée.</a:t>
             </a:r>
           </a:p>
           <a:p/>
@@ -1163,7 +1163,7 @@
           <a:p/>
           <a:p>
             <a:r>
-              <a:t>« Pour résumer : huit fonctionnalités livrées et intégrées, 186 tests verts, une application en ligne pour environ zéro dollar par mois, et une infrastructure entièrement décrite en code — n'importe qui peut la redéployer d'une commande.</a:t>
+              <a:t>« Pour résumer : neuf fonctionnalités livrées et intégrées, 199 tests verts, une application en ligne pour environ zéro dollar par mois, et une infrastructure entièrement décrite en code — n'importe qui peut la redéployer d'une commande.</a:t>
             </a:r>
           </a:p>
           <a:p/>
@@ -1191,7 +1191,12 @@
           </a:p>
           <a:p>
             <a:r>
-              <a:t>· Pourquoi le patient ne réserve pas ? → il appelle, c'est le flux réel (Souleymane)</a:t>
+              <a:t>· Le patient peut-il réserver seul ? → oui, et il peut aussi appeler ; deux canaux, un seul agenda, et la base interdit le doublon entre les deux (Souleymane)</a:t>
+            </a:r>
+          </a:p>
+          <a:p>
+            <a:r>
+              <a:t>· Pourquoi le patient ne peut-il pas annuler ? → l'annulation suppose un délai minimum (UC-07) que nous n'avons pas implémenté ; nous n'avons pas voulu livrer l'une sans l'autre (Souleymane)</a:t>
             </a:r>
           </a:p>
           <a:p>
@@ -1211,7 +1216,7 @@
           </a:p>
           <a:p>
             <a:r>
-              <a:t>· Comment testez-vous ? → 186 tests, CI bloquante sur build et tests (Larbi)</a:t>
+              <a:t>· Comment testez-vous ? → 199 tests, CI bloquante sur build et tests (Larbi)</a:t>
             </a:r>
           </a:p>
         </p:txBody>
@@ -1399,7 +1404,7 @@
           <a:p/>
           <a:p>
             <a:r>
-              <a:t>Si on demande : « pourquoi le patient ne réserve pas lui-même ? » → « le libre-service existe pour l'inscription patient, mais la prise de RDV passe par la réception : c'est ce que fait réellement une petite clinique ».</a:t>
+              <a:t>Si on demande : « et le patient, il fait quoi ? » → « les deux canaux existent. Celui qui appelle est pris en charge par la réception, sans jamais avoir à créer de compte — c'est le patient léger. Celui qui préfère réserver seul le fait depuis son espace. Les deux puisent dans le même agenda, et la base interdit qu'une place soit donnée deux fois. »</a:t>
             </a:r>
           </a:p>
         </p:txBody>
@@ -1970,27 +1975,42 @@
           </a:p>
           <a:p>
             <a:r>
-              <a:t>4. Nouveau rendez-vous → créer le patient → réserver</a:t>
-            </a:r>
-          </a:p>
-          <a:p>
-            <a:r>
-              <a:t>5. Flux du jour → Arrive → Consultation → Termine</a:t>
-            </a:r>
-          </a:p>
-          <a:p>
-            <a:r>
-              <a:t>6. Menu ⋯ → Annuler → motif obligatoire</a:t>
-            </a:r>
-          </a:p>
-          <a:p>
-            <a:r>
-              <a:t>7. Export CSV → ouvrir le fichier téléchargé</a:t>
-            </a:r>
-          </a:p>
-          <a:p>
-            <a:r>
-              <a:t>8. Déconnexion → doctor.demo / Doct0r!Secret → montrer le menu réduit ET la cloche</a:t>
+              <a:t>4. Déconnexion → patient.demo / Pat1ent!Secret → Mes rendez-vous →</a:t>
+            </a:r>
+          </a:p>
+          <a:p>
+            <a:r>
+              <a:t>   Prendre un rendez-vous → réserver le PREMIER créneau de la plage</a:t>
+            </a:r>
+          </a:p>
+          <a:p>
+            <a:r>
+              <a:t>5. Retour admin.demo → Nouveau rendez-vous → MARQUER UN TEMPS :</a:t>
+            </a:r>
+          </a:p>
+          <a:p>
+            <a:r>
+              <a:t>   le créneau pris en ligne n'est plus dans la liste → réserver le suivant</a:t>
+            </a:r>
+          </a:p>
+          <a:p>
+            <a:r>
+              <a:t>6. Flux du jour → Arrive → Consultation → Termine</a:t>
+            </a:r>
+          </a:p>
+          <a:p>
+            <a:r>
+              <a:t>7. Menu ⋯ → Annuler → motif obligatoire</a:t>
+            </a:r>
+          </a:p>
+          <a:p>
+            <a:r>
+              <a:t>8. Export CSV → ouvrir le fichier téléchargé</a:t>
+            </a:r>
+          </a:p>
+          <a:p>
+            <a:r>
+              <a:t>9. Déconnexion → doctor.demo / Doct0r!Secret → montrer le menu réduit ET la cloche</a:t>
             </a:r>
           </a:p>
           <a:p/>
@@ -7692,7 +7712,7 @@
                 </a:solidFill>
                 <a:latin typeface="Calibri"/>
               </a:rPr>
-              <a:t>186</a:t>
+              <a:t>199</a:t>
             </a:r>
           </a:p>
           <a:p>
@@ -8514,7 +8534,7 @@
                 </a:solidFill>
                 <a:latin typeface="Calibri"/>
               </a:rPr>
-              <a:t>•  Les 186 tests passent</a:t>
+              <a:t>•  Les 199 tests passent</a:t>
             </a:r>
           </a:p>
           <a:p>
@@ -12352,7 +12372,26 @@
                 </a:solidFill>
                 <a:latin typeface="Calibri"/>
               </a:rPr>
-              <a:t>•  Portail patient en libre-service</a:t>
+              <a:t>•  Annulation par le patient, avec</a:t>
+            </a:r>
+          </a:p>
+          <a:p>
+            <a:pPr algn="l">
+              <a:spcBef>
+                <a:spcPts val="0"/>
+              </a:spcBef>
+              <a:spcAft>
+                <a:spcPts val="300"/>
+              </a:spcAft>
+            </a:pPr>
+            <a:r>
+              <a:rPr sz="1300" b="0">
+                <a:solidFill>
+                  <a:srgbClr val="404040"/>
+                </a:solidFill>
+                <a:latin typeface="Calibri"/>
+              </a:rPr>
+              <a:t>•     son délai minimum</a:t>
             </a:r>
           </a:p>
         </p:txBody>
@@ -14288,7 +14327,7 @@
                 </a:solidFill>
                 <a:latin typeface="Calibri"/>
               </a:rPr>
-              <a:t>8</a:t>
+              <a:t>9</a:t>
             </a:r>
           </a:p>
           <a:p>
@@ -14393,7 +14432,7 @@
                 </a:solidFill>
                 <a:latin typeface="Calibri"/>
               </a:rPr>
-              <a:t>186</a:t>
+              <a:t>199</a:t>
             </a:r>
           </a:p>
           <a:p>
@@ -22095,7 +22134,7 @@
                 </a:solidFill>
                 <a:latin typeface="Calibri"/>
               </a:rPr>
-              <a:t>•  3.  Le Dr Bergeron publie une plage du matin —</a:t>
+              <a:t>•  3.  La Dre Bergeron publie une plage du matin —</a:t>
             </a:r>
           </a:p>
           <a:p>
@@ -22133,45 +22172,83 @@
                 </a:solidFill>
                 <a:latin typeface="Calibri"/>
               </a:rPr>
-              <a:t>•  4.  Un patient appelle : je le crée et je réserve</a:t>
-            </a:r>
-          </a:p>
-          <a:p>
-            <a:pPr algn="l">
-              <a:spcBef>
-                <a:spcPts val="0"/>
-              </a:spcBef>
-              <a:spcAft>
-                <a:spcPts val="300"/>
-              </a:spcAft>
-            </a:pPr>
-            <a:r>
-              <a:rPr sz="1300" b="0">
-                <a:solidFill>
-                  <a:srgbClr val="404040"/>
-                </a:solidFill>
-                <a:latin typeface="Calibri"/>
-              </a:rPr>
-              <a:t>•  5.  Le flux du jour : arrivé → en consultation → terminé</a:t>
-            </a:r>
-          </a:p>
-          <a:p>
-            <a:pPr algn="l">
-              <a:spcBef>
-                <a:spcPts val="0"/>
-              </a:spcBef>
-              <a:spcAft>
-                <a:spcPts val="300"/>
-              </a:spcAft>
-            </a:pPr>
-            <a:r>
-              <a:rPr sz="1300" b="0">
-                <a:solidFill>
-                  <a:srgbClr val="404040"/>
-                </a:solidFill>
-                <a:latin typeface="Calibri"/>
-              </a:rPr>
-              <a:t>•  6.  Un patient annule : motif obligatoire,</a:t>
+              <a:t>•  4.  Une patiente réserve seule, depuis son espace</a:t>
+            </a:r>
+          </a:p>
+          <a:p>
+            <a:pPr algn="l">
+              <a:spcBef>
+                <a:spcPts val="0"/>
+              </a:spcBef>
+              <a:spcAft>
+                <a:spcPts val="300"/>
+              </a:spcAft>
+            </a:pPr>
+            <a:r>
+              <a:rPr sz="1300" b="0">
+                <a:solidFill>
+                  <a:srgbClr val="404040"/>
+                </a:solidFill>
+                <a:latin typeface="Calibri"/>
+              </a:rPr>
+              <a:t>•  5.  Un autre patient appelle : le créneau qu'elle a pris</a:t>
+            </a:r>
+          </a:p>
+          <a:p>
+            <a:pPr algn="l">
+              <a:spcBef>
+                <a:spcPts val="0"/>
+              </a:spcBef>
+              <a:spcAft>
+                <a:spcPts val="300"/>
+              </a:spcAft>
+            </a:pPr>
+            <a:r>
+              <a:rPr sz="1300" b="0">
+                <a:solidFill>
+                  <a:srgbClr val="404040"/>
+                </a:solidFill>
+                <a:latin typeface="Calibri"/>
+              </a:rPr>
+              <a:t>•       a disparu de ma liste — je le crée et je réserve</a:t>
+            </a:r>
+          </a:p>
+          <a:p>
+            <a:pPr algn="l">
+              <a:spcBef>
+                <a:spcPts val="0"/>
+              </a:spcBef>
+              <a:spcAft>
+                <a:spcPts val="300"/>
+              </a:spcAft>
+            </a:pPr>
+            <a:r>
+              <a:rPr sz="1300" b="0">
+                <a:solidFill>
+                  <a:srgbClr val="404040"/>
+                </a:solidFill>
+                <a:latin typeface="Calibri"/>
+              </a:rPr>
+              <a:t>•  6.  Le flux du jour : arrivé → en consultation → terminé</a:t>
+            </a:r>
+          </a:p>
+          <a:p>
+            <a:pPr algn="l">
+              <a:spcBef>
+                <a:spcPts val="0"/>
+              </a:spcBef>
+              <a:spcAft>
+                <a:spcPts val="300"/>
+              </a:spcAft>
+            </a:pPr>
+            <a:r>
+              <a:rPr sz="1300" b="0">
+                <a:solidFill>
+                  <a:srgbClr val="404040"/>
+                </a:solidFill>
+                <a:latin typeface="Calibri"/>
+              </a:rPr>
+              <a:t>•  7.  Un patient annule : motif obligatoire,</a:t>
             </a:r>
           </a:p>
           <a:p>
@@ -22209,26 +22286,26 @@
                 </a:solidFill>
                 <a:latin typeface="Calibri"/>
               </a:rPr>
-              <a:t>•  7.  J'exporte les rendez-vous du mois en CSV</a:t>
-            </a:r>
-          </a:p>
-          <a:p>
-            <a:pPr algn="l">
-              <a:spcBef>
-                <a:spcPts val="0"/>
-              </a:spcBef>
-              <a:spcAft>
-                <a:spcPts val="300"/>
-              </a:spcAft>
-            </a:pPr>
-            <a:r>
-              <a:rPr sz="1300" b="0">
-                <a:solidFill>
-                  <a:srgbClr val="404040"/>
-                </a:solidFill>
-                <a:latin typeface="Calibri"/>
-              </a:rPr>
-              <a:t>•  8.  Je bascule sur le compte médecin :</a:t>
+              <a:t>•  8.  J'exporte les rendez-vous du mois en CSV</a:t>
+            </a:r>
+          </a:p>
+          <a:p>
+            <a:pPr algn="l">
+              <a:spcBef>
+                <a:spcPts val="0"/>
+              </a:spcBef>
+              <a:spcAft>
+                <a:spcPts val="300"/>
+              </a:spcAft>
+            </a:pPr>
+            <a:r>
+              <a:rPr sz="1300" b="0">
+                <a:solidFill>
+                  <a:srgbClr val="404040"/>
+                </a:solidFill>
+                <a:latin typeface="Calibri"/>
+              </a:rPr>
+              <a:t>•  9.  Je bascule sur le compte médecin :</a:t>
             </a:r>
           </a:p>
           <a:p>
@@ -22865,7 +22942,26 @@
                 </a:solidFill>
                 <a:latin typeface="Calibri"/>
               </a:rPr>
-              <a:t>Réception : admin.demo@mediplan.test    ·    Médecin : doctor.demo@mediplan.test</a:t>
+              <a:t>Réception : admin.demo@mediplan.test    ·    Patiente : patient.demo@mediplan.test</a:t>
+            </a:r>
+          </a:p>
+          <a:p>
+            <a:pPr algn="ctr">
+              <a:spcBef>
+                <a:spcPts val="0"/>
+              </a:spcBef>
+              <a:spcAft>
+                <a:spcPts val="400"/>
+              </a:spcAft>
+            </a:pPr>
+            <a:r>
+              <a:rPr sz="1500" b="0">
+                <a:solidFill>
+                  <a:srgbClr val="9FC8F5"/>
+                </a:solidFill>
+                <a:latin typeface="Calibri"/>
+              </a:rPr>
+              <a:t>Médecin : doctor.demo@mediplan.test</a:t>
             </a:r>
           </a:p>
           <a:p>

</xml_diff>

<commit_message>
docs: aligne les livrables sur les KPI reels et la suppression de plage
Scenario : le discours n'a plus a excuser deux tuiles « bientot » — les
trois portent sur la journee et sont calculees. Ajoute l'interdit de
supprimer une plage qui porte des rendez-vous (l'application refuse).

Document de tests : 203 tests (70 backend, 133 frontend), 29 PR, et le
bogue 5.7 — le creneau qui survivait a sa plage. Il illustre un point de
methode : corriger un defaut peut en rendre un autre atteignable.

Support : chiffres a jour, PPTX regenere (16 diapositives).
</commit_message>
<xml_diff>
--- a/docs/presentation/MediPlan-Presentation-Finale.pptx
+++ b/docs/presentation/MediPlan-Presentation-Finale.pptx
@@ -699,7 +699,7 @@
           <a:p/>
           <a:p>
             <a:r>
-              <a:t>« Nous avons 199 tests automatisés : 67 côté serveur, 132 côté interface. Ils tournent à chaque push, et une pull request dont la CI est rouge n'est pas fusionnée.</a:t>
+              <a:t>« Nous avons 203 tests automatisés : 70 côté serveur, 133 côté interface. Ils tournent à chaque push, et une pull request dont la CI est rouge n'est pas fusionnée.</a:t>
             </a:r>
           </a:p>
           <a:p/>
@@ -1163,7 +1163,7 @@
           <a:p/>
           <a:p>
             <a:r>
-              <a:t>« Pour résumer : neuf fonctionnalités livrées et intégrées, 199 tests verts, une application en ligne pour environ zéro dollar par mois, et une infrastructure entièrement décrite en code — n'importe qui peut la redéployer d'une commande.</a:t>
+              <a:t>« Pour résumer : neuf fonctionnalités livrées et intégrées, 203 tests verts, une application en ligne pour environ zéro dollar par mois, et une infrastructure entièrement décrite en code — n'importe qui peut la redéployer d'une commande.</a:t>
             </a:r>
           </a:p>
           <a:p/>
@@ -1216,7 +1216,7 @@
           </a:p>
           <a:p>
             <a:r>
-              <a:t>· Comment testez-vous ? → 199 tests, CI bloquante sur build et tests (Larbi)</a:t>
+              <a:t>· Comment testez-vous ? → 203 tests, CI bloquante sur build et tests (Larbi)</a:t>
             </a:r>
           </a:p>
         </p:txBody>
@@ -7712,7 +7712,7 @@
                 </a:solidFill>
                 <a:latin typeface="Calibri"/>
               </a:rPr>
-              <a:t>199</a:t>
+              <a:t>203</a:t>
             </a:r>
           </a:p>
           <a:p>
@@ -8534,7 +8534,7 @@
                 </a:solidFill>
                 <a:latin typeface="Calibri"/>
               </a:rPr>
-              <a:t>•  Les 199 tests passent</a:t>
+              <a:t>•  Les 203 tests passent</a:t>
             </a:r>
           </a:p>
           <a:p>
@@ -14432,7 +14432,7 @@
                 </a:solidFill>
                 <a:latin typeface="Calibri"/>
               </a:rPr>
-              <a:t>199</a:t>
+              <a:t>203</a:t>
             </a:r>
           </a:p>
           <a:p>

</xml_diff>